<commit_message>
docs: drop in real screenshots, embed them in the .pptx
All 8 screenshots captured via Claude-for-Chrome (saved as GIFs because
Teams' CSP blocked direct PNG export, then converted last-frame to PNG
locally — multi-frame GIFs captured the populated end-state on the
add-form one).

USERGUIDE.md placeholders replaced with real <img> refs. Added two
extra inline images (Lines view + Group-by-client) that weren't in the
original placeholder set but the captures cover them nicely.

build-overview-pptx.py now prefers docs/screenshots/NN-*.png when the
file exists, falling back to the generated placeholder. Regenerated
deck is 2.8 MB (up from 213 KB) with real screenshots embedded.

Co-Authored-By: Claude Opus 4.7 (1M context) <noreply@anthropic.com>
</commit_message>
<xml_diff>
--- a/docs/DayReminders-Overview.pptx
+++ b/docs/DayReminders-Overview.pptx
@@ -3452,7 +3452,7 @@
       </p:sp>
       <p:pic>
         <p:nvPicPr>
-          <p:cNvPr id="4" name="Picture 3" descr="image.png"/>
+          <p:cNvPr id="4" name="Picture 3" descr="01-left-rail.png"/>
           <p:cNvPicPr>
             <a:picLocks noChangeAspect="1"/>
           </p:cNvPicPr>
@@ -3731,7 +3731,7 @@
       </p:sp>
       <p:pic>
         <p:nvPicPr>
-          <p:cNvPr id="4" name="Picture 3" descr="image.png"/>
+          <p:cNvPr id="4" name="Picture 3" descr="02-add-form.png"/>
           <p:cNvPicPr>
             <a:picLocks noChangeAspect="1"/>
           </p:cNvPicPr>
@@ -4355,7 +4355,7 @@
       </p:sp>
       <p:pic>
         <p:nvPicPr>
-          <p:cNvPr id="4" name="Picture 3" descr="image.png"/>
+          <p:cNvPr id="4" name="Picture 3" descr="03-lines-view.png"/>
           <p:cNvPicPr>
             <a:picLocks noChangeAspect="1"/>
           </p:cNvPicPr>
@@ -4641,7 +4641,7 @@
       </p:sp>
       <p:pic>
         <p:nvPicPr>
-          <p:cNvPr id="4" name="Picture 3" descr="image.png"/>
+          <p:cNvPr id="4" name="Picture 3" descr="04-week-view.png"/>
           <p:cNvPicPr>
             <a:picLocks noChangeAspect="1"/>
           </p:cNvPicPr>
@@ -4962,7 +4962,7 @@
       </p:sp>
       <p:pic>
         <p:nvPicPr>
-          <p:cNvPr id="4" name="Picture 3" descr="image.png"/>
+          <p:cNvPr id="4" name="Picture 3" descr="05-group-by-client.png"/>
           <p:cNvPicPr>
             <a:picLocks noChangeAspect="1"/>
           </p:cNvPicPr>
@@ -5302,7 +5302,7 @@
       </p:sp>
       <p:pic>
         <p:nvPicPr>
-          <p:cNvPr id="4" name="Picture 3" descr="image.png"/>
+          <p:cNvPr id="4" name="Picture 3" descr="06-proactive-card.png"/>
           <p:cNvPicPr>
             <a:picLocks noChangeAspect="1"/>
           </p:cNvPicPr>

</xml_diff>